<commit_message>
feat(F111): template-aware deck checks and template listing for the pptx skill
inspect_deck now reads the Deck manifest, diffs existing checks against the
prototype pages, and adds four WARN checks: slot capacity, leftover template
samples, repeated layouts and cover focus. list_templates.py prints templates
and slots as compact text. Templates recalibrated so their own pages pass the
existing checks without a manifest.

Co-Authored-By: Claude Opus 5.5 <noreply@anthropic.com>
</commit_message>
<xml_diff>
--- a/src/backend/bisheng/linsight/builtin_skills/bisheng-pptx/templates/blueprint/template.pptx
+++ b/src/backend/bisheng/linsight/builtin_skills/bisheng-pptx/templates/blueprint/template.pptx
@@ -2577,7 +2577,7 @@
               </a:lnSpc>
             </a:pPr>
             <a:r>
-              <a:rPr sz="1400" b="1">
+              <a:rPr sz="1300" b="1">
                 <a:solidFill>
                   <a:srgbClr val="E39A2D"/>
                 </a:solidFill>
@@ -2659,7 +2659,7 @@
               </a:lnSpc>
             </a:pPr>
             <a:r>
-              <a:rPr sz="4000" b="1">
+              <a:rPr sz="4400" b="1">
                 <a:solidFill>
                   <a:srgbClr val="FFFFFF"/>
                 </a:solidFill>
@@ -2940,8 +2940,8 @@
         </p:nvSpPr>
         <p:spPr>
           <a:xfrm>
-            <a:off x="609600" y="6477000"/>
-            <a:ext cx="7112000" cy="177800"/>
+            <a:off x="609600" y="6273800"/>
+            <a:ext cx="7112000" cy="203200"/>
           </a:xfrm>
           <a:prstGeom prst="rect">
             <a:avLst/>
@@ -2960,7 +2960,7 @@
               </a:lnSpc>
             </a:pPr>
             <a:r>
-              <a:rPr sz="900" b="0">
+              <a:rPr sz="1000" b="0">
                 <a:solidFill>
                   <a:srgbClr val="5F6B7A"/>
                 </a:solidFill>
@@ -2980,7 +2980,7 @@
         </p:nvSpPr>
         <p:spPr>
           <a:xfrm>
-            <a:off x="10820400" y="6451600"/>
+            <a:off x="10820400" y="6248400"/>
             <a:ext cx="762000" cy="203200"/>
           </a:xfrm>
           <a:prstGeom prst="rect">
@@ -2989,13 +2989,15 @@
           <a:noFill/>
         </p:spPr>
         <p:txBody>
-          <a:bodyPr wrap="none" lIns="0" rIns="0" tIns="0" bIns="0">
-            <a:spAutoFit/>
-          </a:bodyPr>
-          <a:lstStyle/>
-          <a:p>
-            <a:pPr algn="r"/>
-            <a:fld id="{0512D654-86C3-48D3-B1C2-0193244755C8}" type="slidenum">
+          <a:bodyPr wrap="square" lIns="0" rIns="0" tIns="0" bIns="0">
+            <a:noAutofit/>
+          </a:bodyPr>
+          <a:lstStyle/>
+          <a:p>
+            <a:pPr algn="r">
+              <a:defRPr sz="1000"/>
+            </a:pPr>
+            <a:fld id="{ACCC1D6F-E632-5173-8D38-348CC94325A2}" type="slidenum">
               <a:rPr lang="zh-CN" sz="1000">
                 <a:solidFill>
                   <a:srgbClr val="5F6B7A"/>
@@ -3678,8 +3680,8 @@
         </p:nvSpPr>
         <p:spPr>
           <a:xfrm>
-            <a:off x="609600" y="6477000"/>
-            <a:ext cx="7112000" cy="177800"/>
+            <a:off x="609600" y="6273800"/>
+            <a:ext cx="7112000" cy="203200"/>
           </a:xfrm>
           <a:prstGeom prst="rect">
             <a:avLst/>
@@ -3698,7 +3700,7 @@
               </a:lnSpc>
             </a:pPr>
             <a:r>
-              <a:rPr sz="900" b="0">
+              <a:rPr sz="1000" b="0">
                 <a:solidFill>
                   <a:srgbClr val="5F6B7A"/>
                 </a:solidFill>
@@ -3718,7 +3720,7 @@
         </p:nvSpPr>
         <p:spPr>
           <a:xfrm>
-            <a:off x="10820400" y="6451600"/>
+            <a:off x="10820400" y="6248400"/>
             <a:ext cx="762000" cy="203200"/>
           </a:xfrm>
           <a:prstGeom prst="rect">
@@ -3727,13 +3729,15 @@
           <a:noFill/>
         </p:spPr>
         <p:txBody>
-          <a:bodyPr wrap="none" lIns="0" rIns="0" tIns="0" bIns="0">
-            <a:spAutoFit/>
-          </a:bodyPr>
-          <a:lstStyle/>
-          <a:p>
-            <a:pPr algn="r"/>
-            <a:fld id="{75AF8C11-DCA5-40E1-9946-1C3E2E497930}" type="slidenum">
+          <a:bodyPr wrap="square" lIns="0" rIns="0" tIns="0" bIns="0">
+            <a:noAutofit/>
+          </a:bodyPr>
+          <a:lstStyle/>
+          <a:p>
+            <a:pPr algn="r">
+              <a:defRPr sz="1000"/>
+            </a:pPr>
+            <a:fld id="{90F4976D-EA66-58C4-B60A-9F6FE9EC94C1}" type="slidenum">
               <a:rPr lang="zh-CN" sz="1000">
                 <a:solidFill>
                   <a:srgbClr val="5F6B7A"/>
@@ -4815,8 +4819,8 @@
         </p:nvSpPr>
         <p:spPr>
           <a:xfrm>
-            <a:off x="609600" y="6477000"/>
-            <a:ext cx="7112000" cy="177800"/>
+            <a:off x="609600" y="6273800"/>
+            <a:ext cx="7112000" cy="203200"/>
           </a:xfrm>
           <a:prstGeom prst="rect">
             <a:avLst/>
@@ -4835,7 +4839,7 @@
               </a:lnSpc>
             </a:pPr>
             <a:r>
-              <a:rPr sz="900" b="0">
+              <a:rPr sz="1000" b="0">
                 <a:solidFill>
                   <a:srgbClr val="5F6B7A"/>
                 </a:solidFill>
@@ -4855,7 +4859,7 @@
         </p:nvSpPr>
         <p:spPr>
           <a:xfrm>
-            <a:off x="10820400" y="6451600"/>
+            <a:off x="10820400" y="6248400"/>
             <a:ext cx="762000" cy="203200"/>
           </a:xfrm>
           <a:prstGeom prst="rect">
@@ -4864,13 +4868,15 @@
           <a:noFill/>
         </p:spPr>
         <p:txBody>
-          <a:bodyPr wrap="none" lIns="0" rIns="0" tIns="0" bIns="0">
-            <a:spAutoFit/>
-          </a:bodyPr>
-          <a:lstStyle/>
-          <a:p>
-            <a:pPr algn="r"/>
-            <a:fld id="{3935D2CF-64B4-4CAE-9E39-58A9E3895EB1}" type="slidenum">
+          <a:bodyPr wrap="square" lIns="0" rIns="0" tIns="0" bIns="0">
+            <a:noAutofit/>
+          </a:bodyPr>
+          <a:lstStyle/>
+          <a:p>
+            <a:pPr algn="r">
+              <a:defRPr sz="1000"/>
+            </a:pPr>
+            <a:fld id="{35943F2A-FAAF-56D7-94C4-B9B041325DFC}" type="slidenum">
               <a:rPr lang="zh-CN" sz="1000">
                 <a:solidFill>
                   <a:srgbClr val="5F6B7A"/>
@@ -5876,8 +5882,8 @@
         </p:nvSpPr>
         <p:spPr>
           <a:xfrm>
-            <a:off x="609600" y="6477000"/>
-            <a:ext cx="7112000" cy="177800"/>
+            <a:off x="609600" y="6273800"/>
+            <a:ext cx="7112000" cy="203200"/>
           </a:xfrm>
           <a:prstGeom prst="rect">
             <a:avLst/>
@@ -5896,7 +5902,7 @@
               </a:lnSpc>
             </a:pPr>
             <a:r>
-              <a:rPr sz="900" b="0">
+              <a:rPr sz="1000" b="0">
                 <a:solidFill>
                   <a:srgbClr val="5F6B7A"/>
                 </a:solidFill>
@@ -5916,7 +5922,7 @@
         </p:nvSpPr>
         <p:spPr>
           <a:xfrm>
-            <a:off x="10820400" y="6451600"/>
+            <a:off x="10820400" y="6248400"/>
             <a:ext cx="762000" cy="203200"/>
           </a:xfrm>
           <a:prstGeom prst="rect">
@@ -5925,13 +5931,15 @@
           <a:noFill/>
         </p:spPr>
         <p:txBody>
-          <a:bodyPr wrap="none" lIns="0" rIns="0" tIns="0" bIns="0">
-            <a:spAutoFit/>
-          </a:bodyPr>
-          <a:lstStyle/>
-          <a:p>
-            <a:pPr algn="r"/>
-            <a:fld id="{DE03BE59-B902-4DEE-BCF2-3F1D9FA37983}" type="slidenum">
+          <a:bodyPr wrap="square" lIns="0" rIns="0" tIns="0" bIns="0">
+            <a:noAutofit/>
+          </a:bodyPr>
+          <a:lstStyle/>
+          <a:p>
+            <a:pPr algn="r">
+              <a:defRPr sz="1000"/>
+            </a:pPr>
+            <a:fld id="{F9FB96F5-10DB-52DF-A899-916C9A5CEED0}" type="slidenum">
               <a:rPr lang="zh-CN" sz="1000">
                 <a:solidFill>
                   <a:srgbClr val="5F6B7A"/>
@@ -6854,8 +6862,8 @@
         </p:nvSpPr>
         <p:spPr>
           <a:xfrm>
-            <a:off x="609600" y="6477000"/>
-            <a:ext cx="7112000" cy="177800"/>
+            <a:off x="609600" y="6273800"/>
+            <a:ext cx="7112000" cy="203200"/>
           </a:xfrm>
           <a:prstGeom prst="rect">
             <a:avLst/>
@@ -6874,7 +6882,7 @@
               </a:lnSpc>
             </a:pPr>
             <a:r>
-              <a:rPr sz="900" b="0">
+              <a:rPr sz="1000" b="0">
                 <a:solidFill>
                   <a:srgbClr val="5F6B7A"/>
                 </a:solidFill>
@@ -6894,7 +6902,7 @@
         </p:nvSpPr>
         <p:spPr>
           <a:xfrm>
-            <a:off x="10820400" y="6451600"/>
+            <a:off x="10820400" y="6248400"/>
             <a:ext cx="762000" cy="203200"/>
           </a:xfrm>
           <a:prstGeom prst="rect">
@@ -6903,13 +6911,15 @@
           <a:noFill/>
         </p:spPr>
         <p:txBody>
-          <a:bodyPr wrap="none" lIns="0" rIns="0" tIns="0" bIns="0">
-            <a:spAutoFit/>
-          </a:bodyPr>
-          <a:lstStyle/>
-          <a:p>
-            <a:pPr algn="r"/>
-            <a:fld id="{99CCD8DF-3936-423E-BA3F-1D43B5ABBF1B}" type="slidenum">
+          <a:bodyPr wrap="square" lIns="0" rIns="0" tIns="0" bIns="0">
+            <a:noAutofit/>
+          </a:bodyPr>
+          <a:lstStyle/>
+          <a:p>
+            <a:pPr algn="r">
+              <a:defRPr sz="1000"/>
+            </a:pPr>
+            <a:fld id="{AC34E621-F48A-5079-B147-52840DBB815F}" type="slidenum">
               <a:rPr lang="zh-CN" sz="1000">
                 <a:solidFill>
                   <a:srgbClr val="5F6B7A"/>
@@ -8406,8 +8416,8 @@
         </p:nvSpPr>
         <p:spPr>
           <a:xfrm>
-            <a:off x="609600" y="6477000"/>
-            <a:ext cx="7112000" cy="177800"/>
+            <a:off x="609600" y="6273800"/>
+            <a:ext cx="7112000" cy="203200"/>
           </a:xfrm>
           <a:prstGeom prst="rect">
             <a:avLst/>
@@ -8426,7 +8436,7 @@
               </a:lnSpc>
             </a:pPr>
             <a:r>
-              <a:rPr sz="900" b="0">
+              <a:rPr sz="1000" b="0">
                 <a:solidFill>
                   <a:srgbClr val="5F6B7A"/>
                 </a:solidFill>
@@ -8446,7 +8456,7 @@
         </p:nvSpPr>
         <p:spPr>
           <a:xfrm>
-            <a:off x="10820400" y="6451600"/>
+            <a:off x="10820400" y="6248400"/>
             <a:ext cx="762000" cy="203200"/>
           </a:xfrm>
           <a:prstGeom prst="rect">
@@ -8455,13 +8465,15 @@
           <a:noFill/>
         </p:spPr>
         <p:txBody>
-          <a:bodyPr wrap="none" lIns="0" rIns="0" tIns="0" bIns="0">
-            <a:spAutoFit/>
-          </a:bodyPr>
-          <a:lstStyle/>
-          <a:p>
-            <a:pPr algn="r"/>
-            <a:fld id="{3D032C7C-ACFB-4FED-A505-D2F4B24F16D1}" type="slidenum">
+          <a:bodyPr wrap="square" lIns="0" rIns="0" tIns="0" bIns="0">
+            <a:noAutofit/>
+          </a:bodyPr>
+          <a:lstStyle/>
+          <a:p>
+            <a:pPr algn="r">
+              <a:defRPr sz="1000"/>
+            </a:pPr>
+            <a:fld id="{EC183AD3-8013-53EF-9835-C5707B962D63}" type="slidenum">
               <a:rPr lang="zh-CN" sz="1000">
                 <a:solidFill>
                   <a:srgbClr val="5F6B7A"/>
@@ -11039,8 +11051,8 @@
         </p:nvSpPr>
         <p:spPr>
           <a:xfrm>
-            <a:off x="609600" y="6477000"/>
-            <a:ext cx="7112000" cy="177800"/>
+            <a:off x="609600" y="6273800"/>
+            <a:ext cx="7112000" cy="203200"/>
           </a:xfrm>
           <a:prstGeom prst="rect">
             <a:avLst/>
@@ -11059,7 +11071,7 @@
               </a:lnSpc>
             </a:pPr>
             <a:r>
-              <a:rPr sz="900" b="0">
+              <a:rPr sz="1000" b="0">
                 <a:solidFill>
                   <a:srgbClr val="5F6B7A"/>
                 </a:solidFill>
@@ -11079,7 +11091,7 @@
         </p:nvSpPr>
         <p:spPr>
           <a:xfrm>
-            <a:off x="10820400" y="6451600"/>
+            <a:off x="10820400" y="6248400"/>
             <a:ext cx="762000" cy="203200"/>
           </a:xfrm>
           <a:prstGeom prst="rect">
@@ -11088,13 +11100,15 @@
           <a:noFill/>
         </p:spPr>
         <p:txBody>
-          <a:bodyPr wrap="none" lIns="0" rIns="0" tIns="0" bIns="0">
-            <a:spAutoFit/>
-          </a:bodyPr>
-          <a:lstStyle/>
-          <a:p>
-            <a:pPr algn="r"/>
-            <a:fld id="{F00A07FD-6E3D-4CB8-8F8E-6F43BA89C6E6}" type="slidenum">
+          <a:bodyPr wrap="square" lIns="0" rIns="0" tIns="0" bIns="0">
+            <a:noAutofit/>
+          </a:bodyPr>
+          <a:lstStyle/>
+          <a:p>
+            <a:pPr algn="r">
+              <a:defRPr sz="1000"/>
+            </a:pPr>
+            <a:fld id="{BC7043F9-9E05-511C-8ADA-44367FEA71C7}" type="slidenum">
               <a:rPr lang="zh-CN" sz="1000">
                 <a:solidFill>
                   <a:srgbClr val="5F6B7A"/>
@@ -11680,8 +11694,8 @@
         </p:nvSpPr>
         <p:spPr>
           <a:xfrm>
-            <a:off x="609600" y="6477000"/>
-            <a:ext cx="7112000" cy="177800"/>
+            <a:off x="609600" y="6273800"/>
+            <a:ext cx="7112000" cy="203200"/>
           </a:xfrm>
           <a:prstGeom prst="rect">
             <a:avLst/>
@@ -11700,7 +11714,7 @@
               </a:lnSpc>
             </a:pPr>
             <a:r>
-              <a:rPr sz="900" b="0">
+              <a:rPr sz="1000" b="0">
                 <a:solidFill>
                   <a:srgbClr val="B8C9DE"/>
                 </a:solidFill>
@@ -11720,7 +11734,7 @@
         </p:nvSpPr>
         <p:spPr>
           <a:xfrm>
-            <a:off x="10820400" y="6451600"/>
+            <a:off x="10820400" y="6248400"/>
             <a:ext cx="762000" cy="203200"/>
           </a:xfrm>
           <a:prstGeom prst="rect">
@@ -11729,13 +11743,15 @@
           <a:noFill/>
         </p:spPr>
         <p:txBody>
-          <a:bodyPr wrap="none" lIns="0" rIns="0" tIns="0" bIns="0">
-            <a:spAutoFit/>
-          </a:bodyPr>
-          <a:lstStyle/>
-          <a:p>
-            <a:pPr algn="r"/>
-            <a:fld id="{46A5A11E-7E7A-4A1B-A256-853E3D0A1B1D}" type="slidenum">
+          <a:bodyPr wrap="square" lIns="0" rIns="0" tIns="0" bIns="0">
+            <a:noAutofit/>
+          </a:bodyPr>
+          <a:lstStyle/>
+          <a:p>
+            <a:pPr algn="r">
+              <a:defRPr sz="1000"/>
+            </a:pPr>
+            <a:fld id="{C86DC308-465F-50B7-B3E8-CEE62F495BEA}" type="slidenum">
               <a:rPr lang="zh-CN" sz="1000">
                 <a:solidFill>
                   <a:srgbClr val="B8C9DE"/>
@@ -11856,8 +11872,8 @@
         </p:nvSpPr>
         <p:spPr>
           <a:xfrm>
-            <a:off x="609600" y="6477000"/>
-            <a:ext cx="7112000" cy="177800"/>
+            <a:off x="609600" y="6273800"/>
+            <a:ext cx="7112000" cy="203200"/>
           </a:xfrm>
           <a:prstGeom prst="rect">
             <a:avLst/>
@@ -11876,7 +11892,7 @@
               </a:lnSpc>
             </a:pPr>
             <a:r>
-              <a:rPr sz="900" b="0">
+              <a:rPr sz="1000" b="0">
                 <a:solidFill>
                   <a:srgbClr val="5F6B7A"/>
                 </a:solidFill>
@@ -11896,7 +11912,7 @@
         </p:nvSpPr>
         <p:spPr>
           <a:xfrm>
-            <a:off x="10820400" y="6451600"/>
+            <a:off x="10820400" y="6248400"/>
             <a:ext cx="762000" cy="203200"/>
           </a:xfrm>
           <a:prstGeom prst="rect">
@@ -11905,13 +11921,15 @@
           <a:noFill/>
         </p:spPr>
         <p:txBody>
-          <a:bodyPr wrap="none" lIns="0" rIns="0" tIns="0" bIns="0">
-            <a:spAutoFit/>
-          </a:bodyPr>
-          <a:lstStyle/>
-          <a:p>
-            <a:pPr algn="r"/>
-            <a:fld id="{B1966269-A7D2-406F-BF8B-640934E36604}" type="slidenum">
+          <a:bodyPr wrap="square" lIns="0" rIns="0" tIns="0" bIns="0">
+            <a:noAutofit/>
+          </a:bodyPr>
+          <a:lstStyle/>
+          <a:p>
+            <a:pPr algn="r">
+              <a:defRPr sz="1000"/>
+            </a:pPr>
+            <a:fld id="{8C80EE08-C123-53B8-BD35-0523C4E2CBBB}" type="slidenum">
               <a:rPr lang="zh-CN" sz="1000">
                 <a:solidFill>
                   <a:srgbClr val="5F6B7A"/>
@@ -12234,8 +12252,8 @@
         </p:nvSpPr>
         <p:spPr>
           <a:xfrm>
-            <a:off x="609600" y="6477000"/>
-            <a:ext cx="7112000" cy="177800"/>
+            <a:off x="609600" y="6273800"/>
+            <a:ext cx="7112000" cy="203200"/>
           </a:xfrm>
           <a:prstGeom prst="rect">
             <a:avLst/>
@@ -12254,7 +12272,7 @@
               </a:lnSpc>
             </a:pPr>
             <a:r>
-              <a:rPr sz="900" b="0">
+              <a:rPr sz="1000" b="0">
                 <a:solidFill>
                   <a:srgbClr val="5F6B7A"/>
                 </a:solidFill>
@@ -12274,7 +12292,7 @@
         </p:nvSpPr>
         <p:spPr>
           <a:xfrm>
-            <a:off x="10820400" y="6451600"/>
+            <a:off x="10820400" y="6248400"/>
             <a:ext cx="762000" cy="203200"/>
           </a:xfrm>
           <a:prstGeom prst="rect">
@@ -12283,13 +12301,15 @@
           <a:noFill/>
         </p:spPr>
         <p:txBody>
-          <a:bodyPr wrap="none" lIns="0" rIns="0" tIns="0" bIns="0">
-            <a:spAutoFit/>
-          </a:bodyPr>
-          <a:lstStyle/>
-          <a:p>
-            <a:pPr algn="r"/>
-            <a:fld id="{0BDE97EA-91A8-46B9-BE8C-1BE09C9B3B27}" type="slidenum">
+          <a:bodyPr wrap="square" lIns="0" rIns="0" tIns="0" bIns="0">
+            <a:noAutofit/>
+          </a:bodyPr>
+          <a:lstStyle/>
+          <a:p>
+            <a:pPr algn="r">
+              <a:defRPr sz="1000"/>
+            </a:pPr>
+            <a:fld id="{70769519-AA6C-55E4-A5F2-3BE0E25FCF09}" type="slidenum">
               <a:rPr lang="zh-CN" sz="1000">
                 <a:solidFill>
                   <a:srgbClr val="5F6B7A"/>
@@ -12667,8 +12687,8 @@
         </p:nvSpPr>
         <p:spPr>
           <a:xfrm>
-            <a:off x="609600" y="6477000"/>
-            <a:ext cx="7112000" cy="177800"/>
+            <a:off x="609600" y="6273800"/>
+            <a:ext cx="7112000" cy="203200"/>
           </a:xfrm>
           <a:prstGeom prst="rect">
             <a:avLst/>
@@ -12687,7 +12707,7 @@
               </a:lnSpc>
             </a:pPr>
             <a:r>
-              <a:rPr sz="900" b="0">
+              <a:rPr sz="1000" b="0">
                 <a:solidFill>
                   <a:srgbClr val="5F6B7A"/>
                 </a:solidFill>
@@ -12707,7 +12727,7 @@
         </p:nvSpPr>
         <p:spPr>
           <a:xfrm>
-            <a:off x="10820400" y="6451600"/>
+            <a:off x="10820400" y="6248400"/>
             <a:ext cx="762000" cy="203200"/>
           </a:xfrm>
           <a:prstGeom prst="rect">
@@ -12716,13 +12736,15 @@
           <a:noFill/>
         </p:spPr>
         <p:txBody>
-          <a:bodyPr wrap="none" lIns="0" rIns="0" tIns="0" bIns="0">
-            <a:spAutoFit/>
-          </a:bodyPr>
-          <a:lstStyle/>
-          <a:p>
-            <a:pPr algn="r"/>
-            <a:fld id="{434F16BD-E57F-448C-8565-4EB8D6D10871}" type="slidenum">
+          <a:bodyPr wrap="square" lIns="0" rIns="0" tIns="0" bIns="0">
+            <a:noAutofit/>
+          </a:bodyPr>
+          <a:lstStyle/>
+          <a:p>
+            <a:pPr algn="r">
+              <a:defRPr sz="1000"/>
+            </a:pPr>
+            <a:fld id="{37E0B6E4-9F08-5DAD-A1A8-96959B0CEA23}" type="slidenum">
               <a:rPr lang="zh-CN" sz="1000">
                 <a:solidFill>
                   <a:srgbClr val="5F6B7A"/>
@@ -13415,8 +13437,8 @@
         </p:nvSpPr>
         <p:spPr>
           <a:xfrm>
-            <a:off x="609600" y="6477000"/>
-            <a:ext cx="7112000" cy="177800"/>
+            <a:off x="609600" y="6273800"/>
+            <a:ext cx="7112000" cy="203200"/>
           </a:xfrm>
           <a:prstGeom prst="rect">
             <a:avLst/>
@@ -13435,7 +13457,7 @@
               </a:lnSpc>
             </a:pPr>
             <a:r>
-              <a:rPr sz="900" b="0">
+              <a:rPr sz="1000" b="0">
                 <a:solidFill>
                   <a:srgbClr val="5F6B7A"/>
                 </a:solidFill>
@@ -13455,7 +13477,7 @@
         </p:nvSpPr>
         <p:spPr>
           <a:xfrm>
-            <a:off x="10820400" y="6451600"/>
+            <a:off x="10820400" y="6248400"/>
             <a:ext cx="762000" cy="203200"/>
           </a:xfrm>
           <a:prstGeom prst="rect">
@@ -13464,13 +13486,15 @@
           <a:noFill/>
         </p:spPr>
         <p:txBody>
-          <a:bodyPr wrap="none" lIns="0" rIns="0" tIns="0" bIns="0">
-            <a:spAutoFit/>
-          </a:bodyPr>
-          <a:lstStyle/>
-          <a:p>
-            <a:pPr algn="r"/>
-            <a:fld id="{2285035C-927C-4A3E-BCC9-AE9092F2D680}" type="slidenum">
+          <a:bodyPr wrap="square" lIns="0" rIns="0" tIns="0" bIns="0">
+            <a:noAutofit/>
+          </a:bodyPr>
+          <a:lstStyle/>
+          <a:p>
+            <a:pPr algn="r">
+              <a:defRPr sz="1000"/>
+            </a:pPr>
+            <a:fld id="{E8748B65-304A-5AD3-974C-1D41442544A3}" type="slidenum">
               <a:rPr lang="zh-CN" sz="1000">
                 <a:solidFill>
                   <a:srgbClr val="5F6B7A"/>
@@ -14287,8 +14311,8 @@
         </p:nvSpPr>
         <p:spPr>
           <a:xfrm>
-            <a:off x="609600" y="6477000"/>
-            <a:ext cx="7112000" cy="177800"/>
+            <a:off x="609600" y="6273800"/>
+            <a:ext cx="7112000" cy="203200"/>
           </a:xfrm>
           <a:prstGeom prst="rect">
             <a:avLst/>
@@ -14307,7 +14331,7 @@
               </a:lnSpc>
             </a:pPr>
             <a:r>
-              <a:rPr sz="900" b="0">
+              <a:rPr sz="1000" b="0">
                 <a:solidFill>
                   <a:srgbClr val="5F6B7A"/>
                 </a:solidFill>
@@ -14327,7 +14351,7 @@
         </p:nvSpPr>
         <p:spPr>
           <a:xfrm>
-            <a:off x="10820400" y="6451600"/>
+            <a:off x="10820400" y="6248400"/>
             <a:ext cx="762000" cy="203200"/>
           </a:xfrm>
           <a:prstGeom prst="rect">
@@ -14336,13 +14360,15 @@
           <a:noFill/>
         </p:spPr>
         <p:txBody>
-          <a:bodyPr wrap="none" lIns="0" rIns="0" tIns="0" bIns="0">
-            <a:spAutoFit/>
-          </a:bodyPr>
-          <a:lstStyle/>
-          <a:p>
-            <a:pPr algn="r"/>
-            <a:fld id="{56E586EE-7B6D-4FE0-A273-28A032BC40E1}" type="slidenum">
+          <a:bodyPr wrap="square" lIns="0" rIns="0" tIns="0" bIns="0">
+            <a:noAutofit/>
+          </a:bodyPr>
+          <a:lstStyle/>
+          <a:p>
+            <a:pPr algn="r">
+              <a:defRPr sz="1000"/>
+            </a:pPr>
+            <a:fld id="{C6E8BDC6-0300-50D3-B14B-D912D7BECB48}" type="slidenum">
               <a:rPr lang="zh-CN" sz="1000">
                 <a:solidFill>
                   <a:srgbClr val="5F6B7A"/>
@@ -15370,8 +15396,8 @@
         </p:nvSpPr>
         <p:spPr>
           <a:xfrm>
-            <a:off x="609600" y="6477000"/>
-            <a:ext cx="7112000" cy="177800"/>
+            <a:off x="609600" y="6273800"/>
+            <a:ext cx="7112000" cy="203200"/>
           </a:xfrm>
           <a:prstGeom prst="rect">
             <a:avLst/>
@@ -15390,7 +15416,7 @@
               </a:lnSpc>
             </a:pPr>
             <a:r>
-              <a:rPr sz="900" b="0">
+              <a:rPr sz="1000" b="0">
                 <a:solidFill>
                   <a:srgbClr val="5F6B7A"/>
                 </a:solidFill>
@@ -15410,7 +15436,7 @@
         </p:nvSpPr>
         <p:spPr>
           <a:xfrm>
-            <a:off x="10820400" y="6451600"/>
+            <a:off x="10820400" y="6248400"/>
             <a:ext cx="762000" cy="203200"/>
           </a:xfrm>
           <a:prstGeom prst="rect">
@@ -15419,13 +15445,15 @@
           <a:noFill/>
         </p:spPr>
         <p:txBody>
-          <a:bodyPr wrap="none" lIns="0" rIns="0" tIns="0" bIns="0">
-            <a:spAutoFit/>
-          </a:bodyPr>
-          <a:lstStyle/>
-          <a:p>
-            <a:pPr algn="r"/>
-            <a:fld id="{4550375E-4FF3-4DCB-A53B-5C4B5AC01CE6}" type="slidenum">
+          <a:bodyPr wrap="square" lIns="0" rIns="0" tIns="0" bIns="0">
+            <a:noAutofit/>
+          </a:bodyPr>
+          <a:lstStyle/>
+          <a:p>
+            <a:pPr algn="r">
+              <a:defRPr sz="1000"/>
+            </a:pPr>
+            <a:fld id="{3C4BE9CF-E6C2-5098-8EDA-FE5608DF8627}" type="slidenum">
               <a:rPr lang="zh-CN" sz="1000">
                 <a:solidFill>
                   <a:srgbClr val="5F6B7A"/>

</xml_diff>